<commit_message>
Credit the author on the presentation title slide
The project is solo work, not a team submission, so the deck names its
author rather than leaving the credit blank.

Adds "Dana Wael Alhelal" above the course reference on the title slide,
and sets the same name as the file's author metadata, which previously
read "SDAIA Capstone Team".

Rebuilt and validated; the title slide renders with the new credit clear
of the cards above it and the reference line below.
</commit_message>
<xml_diff>
--- a/presentation/SDAIA_Capstone_Presentation.pptx
+++ b/presentation/SDAIA_Capstone_Presentation.pptx
@@ -1133,7 +1133,7 @@
           <a:p>
             <a:r>
               <a:rPr lang="en-US" dirty="0"/>
-              <a:t>Close on the trade-offs, because a technical evaluation rewards defensible choices more than fashionable ones. The final quote is from the Day 5 slides themselves — end by tying the project back to the course thesis. Then open for questions.</a:t>
+              <a:t>Close on the trade-offs, because a technical evaluation rewards defensible choices more than fashionable ones. The final quote is from the Day 5 slides themselves - end by tying the project back to the course thesis. Then open for questions.</a:t>
             </a:r>
             <a:endParaRPr lang="en-US" dirty="0"/>
           </a:p>
@@ -2601,7 +2601,46 @@
         </p:nvSpPr>
         <p:spPr>
           <a:xfrm>
-            <a:off x="566928" y="5806440"/>
+            <a:off x="566928" y="5413248"/>
+            <a:ext cx="5486400" cy="292608"/>
+          </a:xfrm>
+          <a:prstGeom prst="rect">
+            <a:avLst/>
+          </a:prstGeom>
+          <a:noFill/>
+          <a:ln/>
+        </p:spPr>
+        <p:txBody>
+          <a:bodyPr wrap="square" lIns="0" tIns="0" rIns="0" bIns="0" rtlCol="0" anchor="t"/>
+          <a:lstStyle/>
+          <a:p>
+            <a:pPr algn="l" indent="0" marL="0">
+              <a:buNone/>
+            </a:pPr>
+            <a:r>
+              <a:rPr lang="en-US" sz="1500" b="1" dirty="0">
+                <a:solidFill>
+                  <a:srgbClr val="FFFFFF"/>
+                </a:solidFill>
+                <a:latin typeface="Calibri" pitchFamily="34" charset="0"/>
+                <a:ea typeface="Calibri" pitchFamily="34" charset="-122"/>
+                <a:cs typeface="Calibri" pitchFamily="34" charset="-120"/>
+              </a:rPr>
+              <a:t>Dana Wael Alhelal</a:t>
+            </a:r>
+            <a:endParaRPr lang="en-US" sz="1500" dirty="0"/>
+          </a:p>
+        </p:txBody>
+      </p:sp>
+      <p:sp>
+        <p:nvSpPr>
+          <p:cNvPr id="14" name="Text 12"/>
+          <p:cNvSpPr txBox="1"/>
+          <p:nvPr/>
+        </p:nvSpPr>
+        <p:spPr>
+          <a:xfrm>
+            <a:off x="566928" y="5760720"/>
             <a:ext cx="8229600" cy="274320"/>
           </a:xfrm>
           <a:prstGeom prst="rect">

</xml_diff>